<commit_message>
Add edge computing content to slide 8
Extends the blockchain slide with a 4th topic on edge computing:
how hashing enables tamper-proof, decentralized trust at the
network edge for IoT and edge devices.

https://claude.ai/code/session_01S7azh2PR2F5XrXoWht6ZLp
</commit_message>
<xml_diff>
--- a/Hashing_Teaching_Demo.pptx
+++ b/Hashing_Teaching_Demo.pptx
@@ -1215,7 +1215,7 @@
           <a:p>
             <a:r>
               <a:rPr lang="en-US" dirty="0"/>
-              <a:t>KEY SLIDE: Connect everything together. Each block includes the hash of the previous block. If anyone changes data in Block 1, the hash changes, which breaks Block 2 reference, and so on. This is the core insight of blockchain security. Mention: This is actually related to my own research. I study how blockchain architectures can secure edge computing systems.</a:t>
+              <a:t>KEY SLIDE: Connect everything together. Each block includes the hash of the previous block. If anyone changes data in Block 1, the hash changes, which breaks Block 2 reference, and so on. This is the core insight of blockchain security. NEW: Edge computing extension — explain that IoT sensors, autonomous vehicles, and smart devices at the network edge need to verify data without always reaching the cloud. Hashing provides lightweight integrity checks, and when combined with blockchain, creates a decentralized trust model. Edge nodes can hash sensor readings and chain them into a local ledger, making tampering detectable even without cloud connectivity. Mention: This connects to my own research on how blockchain architectures can secure edge computing systems.</a:t>
             </a:r>
             <a:endParaRPr lang="en-US" dirty="0"/>
           </a:p>
@@ -5922,7 +5922,7 @@
                 <a:ea typeface="Georgia" pitchFamily="34" charset="-122"/>
                 <a:cs typeface="Georgia" pitchFamily="34" charset="-120"/>
               </a:rPr>
-              <a:t>From Hashing to Blockchain</a:t>
+              <a:t>From Hashing to Blockchain &amp; Edge</a:t>
             </a:r>
             <a:endParaRPr lang="en-US" sz="3000" dirty="0"/>
           </a:p>
@@ -6009,30 +6009,30 @@
         <p:spPr>
           <a:xfrm>
             <a:off x="548640" y="1005840"/>
-            <a:ext cx="7315200" cy="411480"/>
-          </a:xfrm>
-          <a:prstGeom prst="rect">
-            <a:avLst/>
-          </a:prstGeom>
-          <a:noFill/>
-          <a:ln/>
-        </p:spPr>
-        <p:txBody>
-          <a:bodyPr wrap="square" rtlCol="0" anchor="ctr"/>
-          <a:lstStyle/>
-          <a:p>
-            <a:pPr indent="0" marL="0">
-              <a:buNone/>
-            </a:pPr>
-            <a:r>
-              <a:rPr lang="en-US" sz="1500" i="1" dirty="0">
+            <a:ext cx="7315200" cy="365760"/>
+          </a:xfrm>
+          <a:prstGeom prst="rect">
+            <a:avLst/>
+          </a:prstGeom>
+          <a:noFill/>
+          <a:ln/>
+        </p:spPr>
+        <p:txBody>
+          <a:bodyPr wrap="square" rtlCol="0" anchor="ctr"/>
+          <a:lstStyle/>
+          <a:p>
+            <a:pPr indent="0" marL="0">
+              <a:buNone/>
+            </a:pPr>
+            <a:r>
+              <a:rPr lang="en-US" sz="1400" i="1" dirty="0">
                 <a:solidFill>
                   <a:srgbClr val="5A7184"/>
                 </a:solidFill>
               </a:rPr>
               <a:t>What if we chain hashes together?</a:t>
             </a:r>
-            <a:endParaRPr lang="en-US" sz="1500" dirty="0"/>
+            <a:endParaRPr lang="en-US" sz="1400" dirty="0"/>
           </a:p>
         </p:txBody>
       </p:sp>
@@ -6044,8 +6044,8 @@
         </p:nvSpPr>
         <p:spPr>
           <a:xfrm>
-            <a:off x="365760" y="1600200"/>
-            <a:ext cx="2560320" cy="2286000"/>
+            <a:off x="365760" y="1417320"/>
+            <a:ext cx="2560320" cy="1737360"/>
           </a:xfrm>
           <a:prstGeom prst="rect">
             <a:avLst/>
@@ -6071,8 +6071,8 @@
         </p:nvSpPr>
         <p:spPr>
           <a:xfrm>
-            <a:off x="365760" y="1600200"/>
-            <a:ext cx="2560320" cy="457200"/>
+            <a:off x="365760" y="1417320"/>
+            <a:ext cx="2560320" cy="365760"/>
           </a:xfrm>
           <a:prstGeom prst="rect">
             <a:avLst/>
@@ -6091,8 +6091,8 @@
         </p:nvSpPr>
         <p:spPr>
           <a:xfrm>
-            <a:off x="365760" y="1600200"/>
-            <a:ext cx="2560320" cy="457200"/>
+            <a:off x="365760" y="1417320"/>
+            <a:ext cx="2560320" cy="365760"/>
           </a:xfrm>
           <a:prstGeom prst="rect">
             <a:avLst/>
@@ -6108,14 +6108,14 @@
               <a:buNone/>
             </a:pPr>
             <a:r>
-              <a:rPr lang="en-US" sz="1500" b="1" dirty="0">
+              <a:rPr lang="en-US" sz="1300" b="1" dirty="0">
                 <a:solidFill>
                   <a:srgbClr val="FFFFFF"/>
                 </a:solidFill>
               </a:rPr>
               <a:t>Block 1</a:t>
             </a:r>
-            <a:endParaRPr lang="en-US" sz="1500" dirty="0"/>
+            <a:endParaRPr lang="en-US" sz="1300" dirty="0"/>
           </a:p>
         </p:txBody>
       </p:sp>
@@ -6127,24 +6127,24 @@
         </p:nvSpPr>
         <p:spPr>
           <a:xfrm>
-            <a:off x="502920" y="2148840"/>
-            <a:ext cx="2286000" cy="1645920"/>
-          </a:xfrm>
-          <a:prstGeom prst="rect">
-            <a:avLst/>
-          </a:prstGeom>
-          <a:noFill/>
-          <a:ln/>
-        </p:spPr>
-        <p:txBody>
-          <a:bodyPr wrap="square" rtlCol="0" anchor="ctr"/>
-          <a:lstStyle/>
-          <a:p>
-            <a:pPr indent="0" marL="0">
-              <a:buNone/>
-            </a:pPr>
-            <a:r>
-              <a:rPr lang="en-US" sz="1100" dirty="0">
+            <a:off x="502920" y="1828800"/>
+            <a:ext cx="2286000" cy="1234440"/>
+          </a:xfrm>
+          <a:prstGeom prst="rect">
+            <a:avLst/>
+          </a:prstGeom>
+          <a:noFill/>
+          <a:ln/>
+        </p:spPr>
+        <p:txBody>
+          <a:bodyPr wrap="square" rtlCol="0" anchor="ctr"/>
+          <a:lstStyle/>
+          <a:p>
+            <a:pPr indent="0" marL="0">
+              <a:buNone/>
+            </a:pPr>
+            <a:r>
+              <a:rPr lang="en-US" sz="1000" dirty="0">
                 <a:solidFill>
                   <a:srgbClr val="FF6B35"/>
                 </a:solidFill>
@@ -6154,40 +6154,28 @@
               </a:rPr>
               <a:t>Prev: 0000...</a:t>
             </a:r>
-            <a:endParaRPr lang="en-US" sz="1100" dirty="0"/>
-          </a:p>
-          <a:p>
-            <a:pPr indent="0" marL="0">
-              <a:buNone/>
-            </a:pPr>
-            <a:endParaRPr lang="en-US" sz="1100" dirty="0"/>
-          </a:p>
-          <a:p>
-            <a:pPr indent="0" marL="0">
-              <a:buNone/>
-            </a:pPr>
-            <a:r>
-              <a:rPr lang="en-US" sz="1200" dirty="0">
+            <a:endParaRPr lang="en-US" sz="1000" dirty="0"/>
+          </a:p>
+          <a:p>
+            <a:pPr indent="0" marL="0">
+              <a:buNone/>
+            </a:pPr>
+            <a:r>
+              <a:rPr lang="en-US" sz="1100" dirty="0">
                 <a:solidFill>
                   <a:srgbClr val="1A1A2E"/>
                 </a:solidFill>
               </a:rPr>
               <a:t>Tx: Alice→Bob $10</a:t>
             </a:r>
-            <a:endParaRPr lang="en-US" sz="1100" dirty="0"/>
-          </a:p>
-          <a:p>
-            <a:pPr indent="0" marL="0">
-              <a:buNone/>
-            </a:pPr>
-            <a:endParaRPr lang="en-US" sz="1100" dirty="0"/>
-          </a:p>
-          <a:p>
-            <a:pPr indent="0" marL="0">
-              <a:buNone/>
-            </a:pPr>
-            <a:r>
-              <a:rPr lang="en-US" sz="1100" b="1" dirty="0">
+            <a:endParaRPr lang="en-US" sz="1000" dirty="0"/>
+          </a:p>
+          <a:p>
+            <a:pPr indent="0" marL="0">
+              <a:buNone/>
+            </a:pPr>
+            <a:r>
+              <a:rPr lang="en-US" sz="1000" b="1" dirty="0">
                 <a:solidFill>
                   <a:srgbClr val="1C7293"/>
                 </a:solidFill>
@@ -6197,7 +6185,7 @@
               </a:rPr>
               <a:t>Hash: 3a7f...</a:t>
             </a:r>
-            <a:endParaRPr lang="en-US" sz="1100" dirty="0"/>
+            <a:endParaRPr lang="en-US" sz="1000" dirty="0"/>
           </a:p>
         </p:txBody>
       </p:sp>
@@ -6209,7 +6197,7 @@
         </p:nvSpPr>
         <p:spPr>
           <a:xfrm>
-            <a:off x="2880360" y="2377440"/>
+            <a:off x="2880360" y="1965960"/>
             <a:ext cx="548640" cy="457200"/>
           </a:xfrm>
           <a:prstGeom prst="rect">
@@ -6226,14 +6214,14 @@
               <a:buNone/>
             </a:pPr>
             <a:r>
-              <a:rPr lang="en-US" sz="2800" dirty="0">
+              <a:rPr lang="en-US" sz="2400" dirty="0">
                 <a:solidFill>
                   <a:srgbClr val="1C7293"/>
                 </a:solidFill>
               </a:rPr>
               <a:t>→</a:t>
             </a:r>
-            <a:endParaRPr lang="en-US" sz="2800" dirty="0"/>
+            <a:endParaRPr lang="en-US" sz="2400" dirty="0"/>
           </a:p>
         </p:txBody>
       </p:sp>
@@ -6245,8 +6233,8 @@
         </p:nvSpPr>
         <p:spPr>
           <a:xfrm>
-            <a:off x="3383280" y="1600200"/>
-            <a:ext cx="2560320" cy="2286000"/>
+            <a:off x="3383280" y="1417320"/>
+            <a:ext cx="2560320" cy="1737360"/>
           </a:xfrm>
           <a:prstGeom prst="rect">
             <a:avLst/>
@@ -6272,8 +6260,8 @@
         </p:nvSpPr>
         <p:spPr>
           <a:xfrm>
-            <a:off x="3383280" y="1600200"/>
-            <a:ext cx="2560320" cy="457200"/>
+            <a:off x="3383280" y="1417320"/>
+            <a:ext cx="2560320" cy="365760"/>
           </a:xfrm>
           <a:prstGeom prst="rect">
             <a:avLst/>
@@ -6292,8 +6280,8 @@
         </p:nvSpPr>
         <p:spPr>
           <a:xfrm>
-            <a:off x="3383280" y="1600200"/>
-            <a:ext cx="2560320" cy="457200"/>
+            <a:off x="3383280" y="1417320"/>
+            <a:ext cx="2560320" cy="365760"/>
           </a:xfrm>
           <a:prstGeom prst="rect">
             <a:avLst/>
@@ -6309,14 +6297,14 @@
               <a:buNone/>
             </a:pPr>
             <a:r>
-              <a:rPr lang="en-US" sz="1500" b="1" dirty="0">
+              <a:rPr lang="en-US" sz="1300" b="1" dirty="0">
                 <a:solidFill>
                   <a:srgbClr val="FFFFFF"/>
                 </a:solidFill>
               </a:rPr>
               <a:t>Block 2</a:t>
             </a:r>
-            <a:endParaRPr lang="en-US" sz="1500" dirty="0"/>
+            <a:endParaRPr lang="en-US" sz="1300" dirty="0"/>
           </a:p>
         </p:txBody>
       </p:sp>
@@ -6328,24 +6316,24 @@
         </p:nvSpPr>
         <p:spPr>
           <a:xfrm>
-            <a:off x="3520440" y="2148840"/>
-            <a:ext cx="2286000" cy="1645920"/>
-          </a:xfrm>
-          <a:prstGeom prst="rect">
-            <a:avLst/>
-          </a:prstGeom>
-          <a:noFill/>
-          <a:ln/>
-        </p:spPr>
-        <p:txBody>
-          <a:bodyPr wrap="square" rtlCol="0" anchor="ctr"/>
-          <a:lstStyle/>
-          <a:p>
-            <a:pPr indent="0" marL="0">
-              <a:buNone/>
-            </a:pPr>
-            <a:r>
-              <a:rPr lang="en-US" sz="1100" dirty="0">
+            <a:off x="3520440" y="1828800"/>
+            <a:ext cx="2286000" cy="1234440"/>
+          </a:xfrm>
+          <a:prstGeom prst="rect">
+            <a:avLst/>
+          </a:prstGeom>
+          <a:noFill/>
+          <a:ln/>
+        </p:spPr>
+        <p:txBody>
+          <a:bodyPr wrap="square" rtlCol="0" anchor="ctr"/>
+          <a:lstStyle/>
+          <a:p>
+            <a:pPr indent="0" marL="0">
+              <a:buNone/>
+            </a:pPr>
+            <a:r>
+              <a:rPr lang="en-US" sz="1000" dirty="0">
                 <a:solidFill>
                   <a:srgbClr val="FF6B35"/>
                 </a:solidFill>
@@ -6355,40 +6343,28 @@
               </a:rPr>
               <a:t>Prev: 3a7f...</a:t>
             </a:r>
-            <a:endParaRPr lang="en-US" sz="1100" dirty="0"/>
-          </a:p>
-          <a:p>
-            <a:pPr indent="0" marL="0">
-              <a:buNone/>
-            </a:pPr>
-            <a:endParaRPr lang="en-US" sz="1100" dirty="0"/>
-          </a:p>
-          <a:p>
-            <a:pPr indent="0" marL="0">
-              <a:buNone/>
-            </a:pPr>
-            <a:r>
-              <a:rPr lang="en-US" sz="1200" dirty="0">
+            <a:endParaRPr lang="en-US" sz="1000" dirty="0"/>
+          </a:p>
+          <a:p>
+            <a:pPr indent="0" marL="0">
+              <a:buNone/>
+            </a:pPr>
+            <a:r>
+              <a:rPr lang="en-US" sz="1100" dirty="0">
                 <a:solidFill>
                   <a:srgbClr val="1A1A2E"/>
                 </a:solidFill>
               </a:rPr>
               <a:t>Tx: Bob→Carol $5</a:t>
             </a:r>
-            <a:endParaRPr lang="en-US" sz="1100" dirty="0"/>
-          </a:p>
-          <a:p>
-            <a:pPr indent="0" marL="0">
-              <a:buNone/>
-            </a:pPr>
-            <a:endParaRPr lang="en-US" sz="1100" dirty="0"/>
-          </a:p>
-          <a:p>
-            <a:pPr indent="0" marL="0">
-              <a:buNone/>
-            </a:pPr>
-            <a:r>
-              <a:rPr lang="en-US" sz="1100" b="1" dirty="0">
+            <a:endParaRPr lang="en-US" sz="1000" dirty="0"/>
+          </a:p>
+          <a:p>
+            <a:pPr indent="0" marL="0">
+              <a:buNone/>
+            </a:pPr>
+            <a:r>
+              <a:rPr lang="en-US" sz="1000" b="1" dirty="0">
                 <a:solidFill>
                   <a:srgbClr val="1C7293"/>
                 </a:solidFill>
@@ -6398,7 +6374,7 @@
               </a:rPr>
               <a:t>Hash: 9b2e...</a:t>
             </a:r>
-            <a:endParaRPr lang="en-US" sz="1100" dirty="0"/>
+            <a:endParaRPr lang="en-US" sz="1000" dirty="0"/>
           </a:p>
         </p:txBody>
       </p:sp>
@@ -6410,7 +6386,7 @@
         </p:nvSpPr>
         <p:spPr>
           <a:xfrm>
-            <a:off x="5897880" y="2377440"/>
+            <a:off x="5897880" y="1965960"/>
             <a:ext cx="548640" cy="457200"/>
           </a:xfrm>
           <a:prstGeom prst="rect">
@@ -6427,14 +6403,14 @@
               <a:buNone/>
             </a:pPr>
             <a:r>
-              <a:rPr lang="en-US" sz="2800" dirty="0">
+              <a:rPr lang="en-US" sz="2400" dirty="0">
                 <a:solidFill>
                   <a:srgbClr val="1C7293"/>
                 </a:solidFill>
               </a:rPr>
               <a:t>→</a:t>
             </a:r>
-            <a:endParaRPr lang="en-US" sz="2800" dirty="0"/>
+            <a:endParaRPr lang="en-US" sz="2400" dirty="0"/>
           </a:p>
         </p:txBody>
       </p:sp>
@@ -6446,8 +6422,8 @@
         </p:nvSpPr>
         <p:spPr>
           <a:xfrm>
-            <a:off x="6400800" y="1600200"/>
-            <a:ext cx="2560320" cy="2286000"/>
+            <a:off x="6400800" y="1417320"/>
+            <a:ext cx="2560320" cy="1737360"/>
           </a:xfrm>
           <a:prstGeom prst="rect">
             <a:avLst/>
@@ -6473,8 +6449,8 @@
         </p:nvSpPr>
         <p:spPr>
           <a:xfrm>
-            <a:off x="6400800" y="1600200"/>
-            <a:ext cx="2560320" cy="457200"/>
+            <a:off x="6400800" y="1417320"/>
+            <a:ext cx="2560320" cy="365760"/>
           </a:xfrm>
           <a:prstGeom prst="rect">
             <a:avLst/>
@@ -6493,8 +6469,8 @@
         </p:nvSpPr>
         <p:spPr>
           <a:xfrm>
-            <a:off x="6400800" y="1600200"/>
-            <a:ext cx="2560320" cy="457200"/>
+            <a:off x="6400800" y="1417320"/>
+            <a:ext cx="2560320" cy="365760"/>
           </a:xfrm>
           <a:prstGeom prst="rect">
             <a:avLst/>
@@ -6510,14 +6486,14 @@
               <a:buNone/>
             </a:pPr>
             <a:r>
-              <a:rPr lang="en-US" sz="1500" b="1" dirty="0">
+              <a:rPr lang="en-US" sz="1300" b="1" dirty="0">
                 <a:solidFill>
                   <a:srgbClr val="FFFFFF"/>
                 </a:solidFill>
               </a:rPr>
               <a:t>Block 3</a:t>
             </a:r>
-            <a:endParaRPr lang="en-US" sz="1500" dirty="0"/>
+            <a:endParaRPr lang="en-US" sz="1300" dirty="0"/>
           </a:p>
         </p:txBody>
       </p:sp>
@@ -6529,24 +6505,24 @@
         </p:nvSpPr>
         <p:spPr>
           <a:xfrm>
-            <a:off x="6537960" y="2148840"/>
-            <a:ext cx="2286000" cy="1645920"/>
-          </a:xfrm>
-          <a:prstGeom prst="rect">
-            <a:avLst/>
-          </a:prstGeom>
-          <a:noFill/>
-          <a:ln/>
-        </p:spPr>
-        <p:txBody>
-          <a:bodyPr wrap="square" rtlCol="0" anchor="ctr"/>
-          <a:lstStyle/>
-          <a:p>
-            <a:pPr indent="0" marL="0">
-              <a:buNone/>
-            </a:pPr>
-            <a:r>
-              <a:rPr lang="en-US" sz="1100" dirty="0">
+            <a:off x="6537960" y="1828800"/>
+            <a:ext cx="2286000" cy="1234440"/>
+          </a:xfrm>
+          <a:prstGeom prst="rect">
+            <a:avLst/>
+          </a:prstGeom>
+          <a:noFill/>
+          <a:ln/>
+        </p:spPr>
+        <p:txBody>
+          <a:bodyPr wrap="square" rtlCol="0" anchor="ctr"/>
+          <a:lstStyle/>
+          <a:p>
+            <a:pPr indent="0" marL="0">
+              <a:buNone/>
+            </a:pPr>
+            <a:r>
+              <a:rPr lang="en-US" sz="1000" dirty="0">
                 <a:solidFill>
                   <a:srgbClr val="FF6B35"/>
                 </a:solidFill>
@@ -6556,40 +6532,28 @@
               </a:rPr>
               <a:t>Prev: 9b2e...</a:t>
             </a:r>
-            <a:endParaRPr lang="en-US" sz="1100" dirty="0"/>
-          </a:p>
-          <a:p>
-            <a:pPr indent="0" marL="0">
-              <a:buNone/>
-            </a:pPr>
-            <a:endParaRPr lang="en-US" sz="1100" dirty="0"/>
-          </a:p>
-          <a:p>
-            <a:pPr indent="0" marL="0">
-              <a:buNone/>
-            </a:pPr>
-            <a:r>
-              <a:rPr lang="en-US" sz="1200" dirty="0">
+            <a:endParaRPr lang="en-US" sz="1000" dirty="0"/>
+          </a:p>
+          <a:p>
+            <a:pPr indent="0" marL="0">
+              <a:buNone/>
+            </a:pPr>
+            <a:r>
+              <a:rPr lang="en-US" sz="1100" dirty="0">
                 <a:solidFill>
                   <a:srgbClr val="1A1A2E"/>
                 </a:solidFill>
               </a:rPr>
               <a:t>Tx: Carol→Dave $3</a:t>
             </a:r>
-            <a:endParaRPr lang="en-US" sz="1100" dirty="0"/>
-          </a:p>
-          <a:p>
-            <a:pPr indent="0" marL="0">
-              <a:buNone/>
-            </a:pPr>
-            <a:endParaRPr lang="en-US" sz="1100" dirty="0"/>
-          </a:p>
-          <a:p>
-            <a:pPr indent="0" marL="0">
-              <a:buNone/>
-            </a:pPr>
-            <a:r>
-              <a:rPr lang="en-US" sz="1100" b="1" dirty="0">
+            <a:endParaRPr lang="en-US" sz="1000" dirty="0"/>
+          </a:p>
+          <a:p>
+            <a:pPr indent="0" marL="0">
+              <a:buNone/>
+            </a:pPr>
+            <a:r>
+              <a:rPr lang="en-US" sz="1000" b="1" dirty="0">
                 <a:solidFill>
                   <a:srgbClr val="1C7293"/>
                 </a:solidFill>
@@ -6599,7 +6563,7 @@
               </a:rPr>
               <a:t>Hash: c41d...</a:t>
             </a:r>
-            <a:endParaRPr lang="en-US" sz="1100" dirty="0"/>
+            <a:endParaRPr lang="en-US" sz="1000" dirty="0"/>
           </a:p>
         </p:txBody>
       </p:sp>
@@ -6611,8 +6575,8 @@
         </p:nvSpPr>
         <p:spPr>
           <a:xfrm>
-            <a:off x="548640" y="4069080"/>
-            <a:ext cx="8046720" cy="594360"/>
+            <a:off x="548640" y="3291840"/>
+            <a:ext cx="8046720" cy="457200"/>
           </a:xfrm>
           <a:prstGeom prst="rect">
             <a:avLst/>
@@ -6633,24 +6597,24 @@
         </p:nvSpPr>
         <p:spPr>
           <a:xfrm>
-            <a:off x="731520" y="4069080"/>
-            <a:ext cx="7680960" cy="594360"/>
-          </a:xfrm>
-          <a:prstGeom prst="rect">
-            <a:avLst/>
-          </a:prstGeom>
-          <a:noFill/>
-          <a:ln/>
-        </p:spPr>
-        <p:txBody>
-          <a:bodyPr wrap="square" rtlCol="0" anchor="ctr"/>
-          <a:lstStyle/>
-          <a:p>
-            <a:pPr indent="0" marL="0">
-              <a:buNone/>
-            </a:pPr>
-            <a:r>
-              <a:rPr lang="en-US" sz="1300" b="1" dirty="0">
+            <a:off x="731520" y="3291840"/>
+            <a:ext cx="7680960" cy="457200"/>
+          </a:xfrm>
+          <a:prstGeom prst="rect">
+            <a:avLst/>
+          </a:prstGeom>
+          <a:noFill/>
+          <a:ln/>
+        </p:spPr>
+        <p:txBody>
+          <a:bodyPr wrap="square" rtlCol="0" anchor="ctr"/>
+          <a:lstStyle/>
+          <a:p>
+            <a:pPr indent="0" marL="0">
+              <a:buNone/>
+            </a:pPr>
+            <a:r>
+              <a:rPr lang="en-US" sz="1200" b="1" dirty="0">
                 <a:solidFill>
                   <a:srgbClr val="FF6B35"/>
                 </a:solidFill>
@@ -6661,14 +6625,111 @@
               <a:buNone/>
             </a:pPr>
             <a:r>
-              <a:rPr lang="en-US" sz="1300" dirty="0">
+              <a:rPr lang="en-US" sz="1200" dirty="0">
                 <a:solidFill>
                   <a:srgbClr val="1A1A2E"/>
                 </a:solidFill>
               </a:rPr>
-              <a:t>Its hash changes → Block 2’s ‘Prev Hash’ mismatches → entire chain breaks! The avalanche effect makes fraud detectable.</a:t>
-            </a:r>
-            <a:endParaRPr lang="en-US" sz="1300" dirty="0"/>
+              <a:t>Its hash changes → Block 2’s ‘Prev Hash’ mismatches → entire chain breaks!</a:t>
+            </a:r>
+            <a:endParaRPr lang="en-US" sz="1200" dirty="0"/>
+          </a:p>
+        </p:txBody>
+      </p:sp>
+      <p:sp>
+        <p:nvSpPr>
+          <p:cNvPr id="22" name="Shape 20"/>
+          <p:cNvSpPr/>
+          <p:nvPr/>
+        </p:nvSpPr>
+        <p:spPr>
+          <a:xfrm>
+            <a:off x="548640" y="3840480"/>
+            <a:ext cx="8046720" cy="868680"/>
+          </a:xfrm>
+          <a:prstGeom prst="rect">
+            <a:avLst/>
+          </a:prstGeom>
+          <a:solidFill>
+            <a:srgbClr val="0B1D3A"/>
+          </a:solidFill>
+          <a:ln/>
+          <a:effectLst>
+            <a:outerShdw sx="100000" sy="100000" kx="0" ky="0" algn="bl" rotWithShape="0" blurRad="101600" dist="38100" dir="8100000">
+              <a:srgbClr val="000000">
+                <a:alpha val="12000"/>
+              </a:srgbClr>
+            </a:outerShdw>
+          </a:effectLst>
+        </p:spPr>
+      </p:sp>
+      <p:sp>
+        <p:nvSpPr>
+          <p:cNvPr id="23" name="Shape 21"/>
+          <p:cNvSpPr/>
+          <p:nvPr/>
+        </p:nvSpPr>
+        <p:spPr>
+          <a:xfrm>
+            <a:off x="548640" y="3840480"/>
+            <a:ext cx="73152" cy="868680"/>
+          </a:xfrm>
+          <a:prstGeom prst="rect">
+            <a:avLst/>
+          </a:prstGeom>
+          <a:solidFill>
+            <a:srgbClr val="21D19F"/>
+          </a:solidFill>
+          <a:ln/>
+        </p:spPr>
+      </p:sp>
+      <p:sp>
+        <p:nvSpPr>
+          <p:cNvPr id="24" name="Text 22"/>
+          <p:cNvSpPr/>
+          <p:nvPr/>
+        </p:nvSpPr>
+        <p:spPr>
+          <a:xfrm>
+            <a:off x="822960" y="3886200"/>
+            <a:ext cx="7589520" cy="777240"/>
+          </a:xfrm>
+          <a:prstGeom prst="rect">
+            <a:avLst/>
+          </a:prstGeom>
+          <a:noFill/>
+          <a:ln/>
+        </p:spPr>
+        <p:txBody>
+          <a:bodyPr wrap="square" rtlCol="0" anchor="ctr"/>
+          <a:lstStyle/>
+          <a:p>
+            <a:pPr indent="0" marL="0">
+              <a:buNone/>
+            </a:pPr>
+            <a:r>
+              <a:rPr lang="en-US" sz="1400" b="1" dirty="0">
+                <a:solidFill>
+                  <a:srgbClr val="21D19F"/>
+                </a:solidFill>
+              </a:rPr>
+              <a:t>Extending to Edge Computing</a:t>
+            </a:r>
+            <a:endParaRPr lang="en-US" sz="1400" dirty="0"/>
+          </a:p>
+          <a:p>
+            <a:pPr indent="0" marL="0">
+              <a:buNone/>
+            </a:pPr>
+            <a:r>
+              <a:rPr lang="en-US" sz="1100" dirty="0">
+                <a:solidFill>
+                  <a:srgbClr val="EAF4F8"/>
+                </a:solidFill>
+              </a:rPr>
+              <a:t>IoT devices and edge nodes generate data far from the cloud. Hashing lets edge devices verify data integrity locally without trusting a central server — blockchain + hashing enables tamper-proof, decentralized trust at the network edge.</a:t>
+            </a:r>
+            <a:endParaRPr lang="en-US" sz="1400" dirty="0"/>
           </a:p>
         </p:txBody>
       </p:sp>

</xml_diff>